<commit_message>
Fix choppy bullet formatting in slides
Opened the deck with PowerPoint COM automation and exported every slide
to PNG for visual review, rather than assuming the pptx was correct from
code alone. Found a real formatting bug across 6 slides: several bullet
lists were built from manually pre-wrapped sentence fragments (one
string per physical line), so each fragment got its own bullet marker --
readable but choppy, and outright bad on the References slide (a single
citation split across 4 separate bullets plus a stray empty one).

Fixed by consolidating each genuine bullet point into one string and
letting python-pptx's word_wrap handle the actual line wrapping, across
References, Discussion, Conclusion & Future Work, and the three
image-sidebar bullet lists (Eigenmode Analysis, Ground Truth, Intervention
Simulation). Re-exported and re-reviewed all 22 slides after the fix to
confirm.

Co-Authored-By: Claude Sonnet 5 <noreply@anthropic.com>
</commit_message>
<xml_diff>
--- a/P30_slides.pptx
+++ b/P30_slides.pptx
@@ -3539,7 +3539,7 @@
               </a:defRPr>
             </a:pPr>
             <a:r>
-              <a:t>• D3's 6 spurious null-space eigenvalues</a:t>
+              <a:t>• D3's 6 spurious null-space eigenvalues (from the proven rank deficiency) sit near the origin, cleanly separated from the 19 real modes near |λ|=1</a:t>
             </a:r>
           </a:p>
           <a:p>
@@ -3554,82 +3554,7 @@
               </a:defRPr>
             </a:pPr>
             <a:r>
-              <a:t>• (from the proven rank deficiency) sit</a:t>
-            </a:r>
-          </a:p>
-          <a:p>
-            <a:pPr>
-              <a:spcAft>
-                <a:spcPts val="800"/>
-              </a:spcAft>
-              <a:defRPr sz="1500">
-                <a:solidFill>
-                  <a:srgbClr val="222222"/>
-                </a:solidFill>
-              </a:defRPr>
-            </a:pPr>
-            <a:r>
-              <a:t>• near the origin, cleanly separated</a:t>
-            </a:r>
-          </a:p>
-          <a:p>
-            <a:pPr>
-              <a:spcAft>
-                <a:spcPts val="800"/>
-              </a:spcAft>
-              <a:defRPr sz="1500">
-                <a:solidFill>
-                  <a:srgbClr val="222222"/>
-                </a:solidFill>
-              </a:defRPr>
-            </a:pPr>
-            <a:r>
-              <a:t>• from the 19 real modes near |λ|=1</a:t>
-            </a:r>
-          </a:p>
-          <a:p>
-            <a:pPr>
-              <a:spcAft>
-                <a:spcPts val="800"/>
-              </a:spcAft>
-              <a:defRPr sz="1500">
-                <a:solidFill>
-                  <a:srgbClr val="222222"/>
-                </a:solidFill>
-              </a:defRPr>
-            </a:pPr>
-            <a:r>
-              <a:t>• This disagreement is NOT resolved from</a:t>
-            </a:r>
-          </a:p>
-          <a:p>
-            <a:pPr>
-              <a:spcAft>
-                <a:spcPts val="800"/>
-              </a:spcAft>
-              <a:defRPr sz="1500">
-                <a:solidFill>
-                  <a:srgbClr val="222222"/>
-                </a:solidFill>
-              </a:defRPr>
-            </a:pPr>
-            <a:r>
-              <a:t>• eigenmodes alone — tested next against</a:t>
-            </a:r>
-          </a:p>
-          <a:p>
-            <a:pPr>
-              <a:spcAft>
-                <a:spcPts val="800"/>
-              </a:spcAft>
-              <a:defRPr sz="1500">
-                <a:solidFill>
-                  <a:srgbClr val="222222"/>
-                </a:solidFill>
-              </a:defRPr>
-            </a:pPr>
-            <a:r>
-              <a:t>• simulated ground truth</a:t>
+              <a:t>• This disagreement is NOT resolved from eigenmodes alone — tested next against simulated ground truth</a:t>
             </a:r>
           </a:p>
         </p:txBody>
@@ -4033,7 +3958,7 @@
               </a:defRPr>
             </a:pPr>
             <a:r>
-              <a:t>• Ground truth: cut each ward's</a:t>
+              <a:t>• Ground truth: cut each ward's contacts 50%, measure the drop in colonized person-days (100 replicates, common random numbers, paired comparison)</a:t>
             </a:r>
           </a:p>
           <a:p>
@@ -4048,112 +3973,7 @@
               </a:defRPr>
             </a:pPr>
             <a:r>
-              <a:t>• contacts 50%, measure the drop</a:t>
-            </a:r>
-          </a:p>
-          <a:p>
-            <a:pPr>
-              <a:spcAft>
-                <a:spcPts val="800"/>
-              </a:spcAft>
-              <a:defRPr sz="1500">
-                <a:solidFill>
-                  <a:srgbClr val="222222"/>
-                </a:solidFill>
-              </a:defRPr>
-            </a:pPr>
-            <a:r>
-              <a:t>• in colonized person-days</a:t>
-            </a:r>
-          </a:p>
-          <a:p>
-            <a:pPr>
-              <a:spcAft>
-                <a:spcPts val="800"/>
-              </a:spcAft>
-              <a:defRPr sz="1500">
-                <a:solidFill>
-                  <a:srgbClr val="222222"/>
-                </a:solidFill>
-              </a:defRPr>
-            </a:pPr>
-            <a:r>
-              <a:t>• (100 replicates, common random</a:t>
-            </a:r>
-          </a:p>
-          <a:p>
-            <a:pPr>
-              <a:spcAft>
-                <a:spcPts val="800"/>
-              </a:spcAft>
-              <a:defRPr sz="1500">
-                <a:solidFill>
-                  <a:srgbClr val="222222"/>
-                </a:solidFill>
-              </a:defRPr>
-            </a:pPr>
-            <a:r>
-              <a:t>• numbers, paired comparison)</a:t>
-            </a:r>
-          </a:p>
-          <a:p>
-            <a:pPr>
-              <a:spcAft>
-                <a:spcPts val="800"/>
-              </a:spcAft>
-              <a:defRPr sz="1500">
-                <a:solidFill>
-                  <a:srgbClr val="222222"/>
-                </a:solidFill>
-              </a:defRPr>
-            </a:pPr>
-            <a:r>
-              <a:t>• </a:t>
-            </a:r>
-          </a:p>
-          <a:p>
-            <a:pPr>
-              <a:spcAft>
-                <a:spcPts val="800"/>
-              </a:spcAft>
-              <a:defRPr sz="1500">
-                <a:solidFill>
-                  <a:srgbClr val="222222"/>
-                </a:solidFill>
-              </a:defRPr>
-            </a:pPr>
-            <a:r>
-              <a:t>• Ranking: Menard 1 &gt; Sorrel 1 &gt;</a:t>
-            </a:r>
-          </a:p>
-          <a:p>
-            <a:pPr>
-              <a:spcAft>
-                <a:spcPts val="800"/>
-              </a:spcAft>
-              <a:defRPr sz="1500">
-                <a:solidFill>
-                  <a:srgbClr val="222222"/>
-                </a:solidFill>
-              </a:defRPr>
-            </a:pPr>
-            <a:r>
-              <a:t>• Menard 2 &gt; Sorrel 2 &gt; Sorrel 0 &gt;</a:t>
-            </a:r>
-          </a:p>
-          <a:p>
-            <a:pPr>
-              <a:spcAft>
-                <a:spcPts val="800"/>
-              </a:spcAft>
-              <a:defRPr sz="1500">
-                <a:solidFill>
-                  <a:srgbClr val="222222"/>
-                </a:solidFill>
-              </a:defRPr>
-            </a:pPr>
-            <a:r>
-              <a:t>• Other</a:t>
+              <a:t>• Ranking: Menard 1 &gt; Sorrel 1 &gt; Menard 2 &gt; Sorrel 2 &gt; Sorrel 0 &gt; Other</a:t>
             </a:r>
           </a:p>
         </p:txBody>
@@ -4751,7 +4571,7 @@
               </a:defRPr>
             </a:pPr>
             <a:r>
-              <a:t>• ground_truth, degree_centrality,</a:t>
+              <a:t>• ground_truth, degree_centrality, and eigenvector_centrality columns look nearly identical</a:t>
             </a:r>
           </a:p>
           <a:p>
@@ -4766,7 +4586,7 @@
               </a:defRPr>
             </a:pPr>
             <a:r>
-              <a:t>• and eigenvector_centrality</a:t>
+              <a:t>• The three koopman columns look comparatively scrambled</a:t>
             </a:r>
           </a:p>
           <a:p>
@@ -4781,127 +4601,7 @@
               </a:defRPr>
             </a:pPr>
             <a:r>
-              <a:t>• columns look nearly identical</a:t>
-            </a:r>
-          </a:p>
-          <a:p>
-            <a:pPr>
-              <a:spcAft>
-                <a:spcPts val="800"/>
-              </a:spcAft>
-              <a:defRPr sz="1500">
-                <a:solidFill>
-                  <a:srgbClr val="222222"/>
-                </a:solidFill>
-              </a:defRPr>
-            </a:pPr>
-            <a:r>
-              <a:t>• </a:t>
-            </a:r>
-          </a:p>
-          <a:p>
-            <a:pPr>
-              <a:spcAft>
-                <a:spcPts val="800"/>
-              </a:spcAft>
-              <a:defRPr sz="1500">
-                <a:solidFill>
-                  <a:srgbClr val="222222"/>
-                </a:solidFill>
-              </a:defRPr>
-            </a:pPr>
-            <a:r>
-              <a:t>• The three koopman columns</a:t>
-            </a:r>
-          </a:p>
-          <a:p>
-            <a:pPr>
-              <a:spcAft>
-                <a:spcPts val="800"/>
-              </a:spcAft>
-              <a:defRPr sz="1500">
-                <a:solidFill>
-                  <a:srgbClr val="222222"/>
-                </a:solidFill>
-              </a:defRPr>
-            </a:pPr>
-            <a:r>
-              <a:t>• look comparatively scrambled</a:t>
-            </a:r>
-          </a:p>
-          <a:p>
-            <a:pPr>
-              <a:spcAft>
-                <a:spcPts val="800"/>
-              </a:spcAft>
-              <a:defRPr sz="1500">
-                <a:solidFill>
-                  <a:srgbClr val="222222"/>
-                </a:solidFill>
-              </a:defRPr>
-            </a:pPr>
-            <a:r>
-              <a:t>• </a:t>
-            </a:r>
-          </a:p>
-          <a:p>
-            <a:pPr>
-              <a:spcAft>
-                <a:spcPts val="800"/>
-              </a:spcAft>
-              <a:defRPr sz="1500">
-                <a:solidFill>
-                  <a:srgbClr val="222222"/>
-                </a:solidFill>
-              </a:defRPr>
-            </a:pPr>
-            <a:r>
-              <a:t>• Nuance: koopman_D1 DOES pick</a:t>
-            </a:r>
-          </a:p>
-          <a:p>
-            <a:pPr>
-              <a:spcAft>
-                <a:spcPts val="800"/>
-              </a:spcAft>
-              <a:defRPr sz="1500">
-                <a:solidFill>
-                  <a:srgbClr val="222222"/>
-                </a:solidFill>
-              </a:defRPr>
-            </a:pPr>
-            <a:r>
-              <a:t>• the #1 ward correctly (Menard 1)</a:t>
-            </a:r>
-          </a:p>
-          <a:p>
-            <a:pPr>
-              <a:spcAft>
-                <a:spcPts val="800"/>
-              </a:spcAft>
-              <a:defRPr sz="1500">
-                <a:solidFill>
-                  <a:srgbClr val="222222"/>
-                </a:solidFill>
-              </a:defRPr>
-            </a:pPr>
-            <a:r>
-              <a:t>• — but has the worst OVERALL</a:t>
-            </a:r>
-          </a:p>
-          <a:p>
-            <a:pPr>
-              <a:spcAft>
-                <a:spcPts val="800"/>
-              </a:spcAft>
-              <a:defRPr sz="1500">
-                <a:solidFill>
-                  <a:srgbClr val="222222"/>
-                </a:solidFill>
-              </a:defRPr>
-            </a:pPr>
-            <a:r>
-              <a:t>• rank correlation of the three</a:t>
+              <a:t>• Nuance: koopman_D1 DOES pick the #1 ward correctly (Menard 1) — but has the worst OVERALL rank correlation of the three</a:t>
             </a:r>
           </a:p>
         </p:txBody>
@@ -5051,7 +4751,7 @@
               </a:defRPr>
             </a:pPr>
             <a:r>
-              <a:t>• Equal-budget framework:</a:t>
+              <a:t>• Equal-budget framework: budget = k × reduction fraction</a:t>
             </a:r>
           </a:p>
           <a:p>
@@ -5066,7 +4766,7 @@
               </a:defRPr>
             </a:pPr>
             <a:r>
-              <a:t>• budget = k × reduction fraction</a:t>
+              <a:t>• Every TARGETED strategy beats BOTH untargeted strategies (random, whole-hospital) at every matching budget</a:t>
             </a:r>
           </a:p>
           <a:p>
@@ -5081,142 +4781,7 @@
               </a:defRPr>
             </a:pPr>
             <a:r>
-              <a:t>• </a:t>
-            </a:r>
-          </a:p>
-          <a:p>
-            <a:pPr>
-              <a:spcAft>
-                <a:spcPts val="800"/>
-              </a:spcAft>
-              <a:defRPr sz="1500">
-                <a:solidFill>
-                  <a:srgbClr val="222222"/>
-                </a:solidFill>
-              </a:defRPr>
-            </a:pPr>
-            <a:r>
-              <a:t>• Every TARGETED strategy beats</a:t>
-            </a:r>
-          </a:p>
-          <a:p>
-            <a:pPr>
-              <a:spcAft>
-                <a:spcPts val="800"/>
-              </a:spcAft>
-              <a:defRPr sz="1500">
-                <a:solidFill>
-                  <a:srgbClr val="222222"/>
-                </a:solidFill>
-              </a:defRPr>
-            </a:pPr>
-            <a:r>
-              <a:t>• BOTH untargeted strategies</a:t>
-            </a:r>
-          </a:p>
-          <a:p>
-            <a:pPr>
-              <a:spcAft>
-                <a:spcPts val="800"/>
-              </a:spcAft>
-              <a:defRPr sz="1500">
-                <a:solidFill>
-                  <a:srgbClr val="222222"/>
-                </a:solidFill>
-              </a:defRPr>
-            </a:pPr>
-            <a:r>
-              <a:t>• (random, whole-hospital) at</a:t>
-            </a:r>
-          </a:p>
-          <a:p>
-            <a:pPr>
-              <a:spcAft>
-                <a:spcPts val="800"/>
-              </a:spcAft>
-              <a:defRPr sz="1500">
-                <a:solidFill>
-                  <a:srgbClr val="222222"/>
-                </a:solidFill>
-              </a:defRPr>
-            </a:pPr>
-            <a:r>
-              <a:t>• every matching budget</a:t>
-            </a:r>
-          </a:p>
-          <a:p>
-            <a:pPr>
-              <a:spcAft>
-                <a:spcPts val="800"/>
-              </a:spcAft>
-              <a:defRPr sz="1500">
-                <a:solidFill>
-                  <a:srgbClr val="222222"/>
-                </a:solidFill>
-              </a:defRPr>
-            </a:pPr>
-            <a:r>
-              <a:t>• </a:t>
-            </a:r>
-          </a:p>
-          <a:p>
-            <a:pPr>
-              <a:spcAft>
-                <a:spcPts val="800"/>
-              </a:spcAft>
-              <a:defRPr sz="1500">
-                <a:solidFill>
-                  <a:srgbClr val="222222"/>
-                </a:solidFill>
-              </a:defRPr>
-            </a:pPr>
-            <a:r>
-              <a:t>• At k=2: koopman_D2/D3 slightly</a:t>
-            </a:r>
-          </a:p>
-          <a:p>
-            <a:pPr>
-              <a:spcAft>
-                <a:spcPts val="800"/>
-              </a:spcAft>
-              <a:defRPr sz="1500">
-                <a:solidFill>
-                  <a:srgbClr val="222222"/>
-                </a:solidFill>
-              </a:defRPr>
-            </a:pPr>
-            <a:r>
-              <a:t>• beats degree-targeting — a higher</a:t>
-            </a:r>
-          </a:p>
-          <a:p>
-            <a:pPr>
-              <a:spcAft>
-                <a:spcPts val="800"/>
-              </a:spcAft>
-              <a:defRPr sz="1500">
-                <a:solidFill>
-                  <a:srgbClr val="222222"/>
-                </a:solidFill>
-              </a:defRPr>
-            </a:pPr>
-            <a:r>
-              <a:t>• overall correlation doesn't</a:t>
-            </a:r>
-          </a:p>
-          <a:p>
-            <a:pPr>
-              <a:spcAft>
-                <a:spcPts val="800"/>
-              </a:spcAft>
-              <a:defRPr sz="1500">
-                <a:solidFill>
-                  <a:srgbClr val="222222"/>
-                </a:solidFill>
-              </a:defRPr>
-            </a:pPr>
-            <a:r>
-              <a:t>• guarantee the better k=2 pick</a:t>
+              <a:t>• At k=2: koopman_D2/D3 slightly beats degree-targeting — a higher overall correlation doesn't guarantee the better k=2 pick</a:t>
             </a:r>
           </a:p>
         </p:txBody>
@@ -5884,7 +5449,7 @@
               </a:defRPr>
             </a:pPr>
             <a:r>
-              <a:t>• The Koopman/EDMD machinery works and was built/verified rigorously</a:t>
+              <a:t>• The Koopman/EDMD machinery works and was built/verified rigorously (exact recovery on synthetic systems, closed-form agreement, 179 tests)</a:t>
             </a:r>
           </a:p>
           <a:p>
@@ -5899,7 +5464,7 @@
               </a:defRPr>
             </a:pPr>
             <a:r>
-              <a:t>• (exact recovery on synthetic systems, closed-form agreement, 179 tests)</a:t>
+              <a:t>• On THIS dataset, it does not outperform simpler alternatives — reported honestly, with three concrete, verifiable reasons:</a:t>
             </a:r>
           </a:p>
           <a:p>
@@ -5907,6 +5472,51 @@
               <a:spcAft>
                 <a:spcPts val="1000"/>
               </a:spcAft>
+              <a:defRPr sz="1700">
+                <a:solidFill>
+                  <a:srgbClr val="222222"/>
+                </a:solidFill>
+              </a:defRPr>
+            </a:pPr>
+            <a:r>
+              <a:t>   - (a) SIS calibration sits on a weakly-identified ridge (~16 real snapshots)</a:t>
+            </a:r>
+          </a:p>
+          <a:p>
+            <a:pPr>
+              <a:spcAft>
+                <a:spcPts val="1000"/>
+              </a:spcAft>
+              <a:defRPr sz="1700">
+                <a:solidFill>
+                  <a:srgbClr val="222222"/>
+                </a:solidFill>
+              </a:defRPr>
+            </a:pPr>
+            <a:r>
+              <a:t>   - (b) D3, the “network-aware” dictionary, is PROVABLY no richer than D2</a:t>
+            </a:r>
+          </a:p>
+          <a:p>
+            <a:pPr>
+              <a:spcAft>
+                <a:spcPts val="1000"/>
+              </a:spcAft>
+              <a:defRPr sz="1700">
+                <a:solidFill>
+                  <a:srgbClr val="222222"/>
+                </a:solidFill>
+              </a:defRPr>
+            </a:pPr>
+            <a:r>
+              <a:t>   - (c) raw ward contact volume is a strong, nearly-free predictor</a:t>
+            </a:r>
+          </a:p>
+          <a:p>
+            <a:pPr>
+              <a:spcAft>
+                <a:spcPts val="1000"/>
+              </a:spcAft>
               <a:defRPr sz="2000">
                 <a:solidFill>
                   <a:srgbClr val="222222"/>
@@ -5914,97 +5524,7 @@
               </a:defRPr>
             </a:pPr>
             <a:r>
-              <a:t>• On THIS dataset, it does not outperform simpler alternatives — reported</a:t>
-            </a:r>
-          </a:p>
-          <a:p>
-            <a:pPr>
-              <a:spcAft>
-                <a:spcPts val="1000"/>
-              </a:spcAft>
-              <a:defRPr sz="2000">
-                <a:solidFill>
-                  <a:srgbClr val="222222"/>
-                </a:solidFill>
-              </a:defRPr>
-            </a:pPr>
-            <a:r>
-              <a:t>• honestly, with three concrete, verifiable reasons:</a:t>
-            </a:r>
-          </a:p>
-          <a:p>
-            <a:pPr>
-              <a:spcAft>
-                <a:spcPts val="1000"/>
-              </a:spcAft>
-              <a:defRPr sz="1700">
-                <a:solidFill>
-                  <a:srgbClr val="222222"/>
-                </a:solidFill>
-              </a:defRPr>
-            </a:pPr>
-            <a:r>
-              <a:t>   - (a) SIS calibration sits on a weakly-identified ridge (~16 real snapshots)</a:t>
-            </a:r>
-          </a:p>
-          <a:p>
-            <a:pPr>
-              <a:spcAft>
-                <a:spcPts val="1000"/>
-              </a:spcAft>
-              <a:defRPr sz="1700">
-                <a:solidFill>
-                  <a:srgbClr val="222222"/>
-                </a:solidFill>
-              </a:defRPr>
-            </a:pPr>
-            <a:r>
-              <a:t>   - (b) D3, the “network-aware” dictionary, is PROVABLY no richer than D2</a:t>
-            </a:r>
-          </a:p>
-          <a:p>
-            <a:pPr>
-              <a:spcAft>
-                <a:spcPts val="1000"/>
-              </a:spcAft>
-              <a:defRPr sz="1700">
-                <a:solidFill>
-                  <a:srgbClr val="222222"/>
-                </a:solidFill>
-              </a:defRPr>
-            </a:pPr>
-            <a:r>
-              <a:t>   - (c) raw ward contact volume is a strong, nearly-free predictor</a:t>
-            </a:r>
-          </a:p>
-          <a:p>
-            <a:pPr>
-              <a:spcAft>
-                <a:spcPts val="1000"/>
-              </a:spcAft>
-              <a:defRPr sz="2000">
-                <a:solidFill>
-                  <a:srgbClr val="222222"/>
-                </a:solidFill>
-              </a:defRPr>
-            </a:pPr>
-            <a:r>
-              <a:t>• Targeting still matters enormously, independent of which score is used —</a:t>
-            </a:r>
-          </a:p>
-          <a:p>
-            <a:pPr>
-              <a:spcAft>
-                <a:spcPts val="1000"/>
-              </a:spcAft>
-              <a:defRPr sz="2000">
-                <a:solidFill>
-                  <a:srgbClr val="222222"/>
-                </a:solidFill>
-              </a:defRPr>
-            </a:pPr>
-            <a:r>
-              <a:t>• a practically actionable finding that survives every robustness check</a:t>
+              <a:t>• Targeting still matters enormously, independent of which score is used — a practically actionable finding that survives every robustness check</a:t>
             </a:r>
           </a:p>
         </p:txBody>
@@ -6382,7 +5902,7 @@
               </a:defRPr>
             </a:pPr>
             <a:r>
-              <a:t>• Built a complete, rigorously-tested pipeline: real network → calibrated</a:t>
+              <a:t>• Built a complete, rigorously-tested pipeline: real network → calibrated SIS simulator → EDMD → eigenmodes → validated against simulated ground truth</a:t>
             </a:r>
           </a:p>
           <a:p>
@@ -6397,37 +5917,7 @@
               </a:defRPr>
             </a:pPr>
             <a:r>
-              <a:t>• SIS simulator → EDMD → eigenmodes → validated against simulated ground truth</a:t>
-            </a:r>
-          </a:p>
-          <a:p>
-            <a:pPr>
-              <a:spcAft>
-                <a:spcPts val="1000"/>
-              </a:spcAft>
-              <a:defRPr sz="2000">
-                <a:solidFill>
-                  <a:srgbClr val="222222"/>
-                </a:solidFill>
-              </a:defRPr>
-            </a:pPr>
-            <a:r>
-              <a:t>• Honest answer: network-aware Koopman eigenmodes do not beat simple</a:t>
-            </a:r>
-          </a:p>
-          <a:p>
-            <a:pPr>
-              <a:spcAft>
-                <a:spcPts val="1000"/>
-              </a:spcAft>
-              <a:defRPr sz="2000">
-                <a:solidFill>
-                  <a:srgbClr val="222222"/>
-                </a:solidFill>
-              </a:defRPr>
-            </a:pPr>
-            <a:r>
-              <a:t>• degree centrality for THIS dataset — traced to specific, understood causes</a:t>
+              <a:t>• Honest answer: network-aware Koopman eigenmodes do not beat simple degree centrality for THIS dataset — traced to specific, understood causes</a:t>
             </a:r>
           </a:p>
           <a:p>
@@ -6578,7 +6068,7 @@
               </a:defRPr>
             </a:pPr>
             <a:r>
-              <a:t>• Obadia, T., Silhol, R., Opatowski, L., Temime, L., Legrand, J.,</a:t>
+              <a:t>• Obadia, T., Silhol, R., Opatowski, L., Temime, L., Legrand, J., Thiébaut, A.C.M., et al. (2015). Detailed Contact Data and the Dissemination of Staphylococcus aureus in Hospitals. PLOS Computational Biology, 11(3):e1004170.</a:t>
             </a:r>
           </a:p>
           <a:p>
@@ -6593,112 +6083,7 @@
               </a:defRPr>
             </a:pPr>
             <a:r>
-              <a:t>• Thiébaut, A.C.M., et al. (2015). Detailed Contact Data and the</a:t>
-            </a:r>
-          </a:p>
-          <a:p>
-            <a:pPr>
-              <a:spcAft>
-                <a:spcPts val="1000"/>
-              </a:spcAft>
-              <a:defRPr sz="2000">
-                <a:solidFill>
-                  <a:srgbClr val="222222"/>
-                </a:solidFill>
-              </a:defRPr>
-            </a:pPr>
-            <a:r>
-              <a:t>• Dissemination of Staphylococcus aureus in Hospitals.</a:t>
-            </a:r>
-          </a:p>
-          <a:p>
-            <a:pPr>
-              <a:spcAft>
-                <a:spcPts val="1000"/>
-              </a:spcAft>
-              <a:defRPr sz="2000">
-                <a:solidFill>
-                  <a:srgbClr val="222222"/>
-                </a:solidFill>
-              </a:defRPr>
-            </a:pPr>
-            <a:r>
-              <a:t>• PLOS Computational Biology, 11(3):e1004170.</a:t>
-            </a:r>
-          </a:p>
-          <a:p>
-            <a:pPr>
-              <a:spcAft>
-                <a:spcPts val="1000"/>
-              </a:spcAft>
-              <a:defRPr sz="2000">
-                <a:solidFill>
-                  <a:srgbClr val="222222"/>
-                </a:solidFill>
-              </a:defRPr>
-            </a:pPr>
-            <a:r>
-              <a:t>• </a:t>
-            </a:r>
-          </a:p>
-          <a:p>
-            <a:pPr>
-              <a:spcAft>
-                <a:spcPts val="1000"/>
-              </a:spcAft>
-              <a:defRPr sz="2000">
-                <a:solidFill>
-                  <a:srgbClr val="222222"/>
-                </a:solidFill>
-              </a:defRPr>
-            </a:pPr>
-            <a:r>
-              <a:t>• Duval, A., Obadia, T., Martinet, L., Boëlle, P.Y., Fleury, E.,</a:t>
-            </a:r>
-          </a:p>
-          <a:p>
-            <a:pPr>
-              <a:spcAft>
-                <a:spcPts val="1000"/>
-              </a:spcAft>
-              <a:defRPr sz="2000">
-                <a:solidFill>
-                  <a:srgbClr val="222222"/>
-                </a:solidFill>
-              </a:defRPr>
-            </a:pPr>
-            <a:r>
-              <a:t>• Guillemot, D., et al. (2018). Measuring dynamic social contacts</a:t>
-            </a:r>
-          </a:p>
-          <a:p>
-            <a:pPr>
-              <a:spcAft>
-                <a:spcPts val="1000"/>
-              </a:spcAft>
-              <a:defRPr sz="2000">
-                <a:solidFill>
-                  <a:srgbClr val="222222"/>
-                </a:solidFill>
-              </a:defRPr>
-            </a:pPr>
-            <a:r>
-              <a:t>• in a rehabilitation hospital: effect of wards, patient and staff</a:t>
-            </a:r>
-          </a:p>
-          <a:p>
-            <a:pPr>
-              <a:spcAft>
-                <a:spcPts val="1000"/>
-              </a:spcAft>
-              <a:defRPr sz="2000">
-                <a:solidFill>
-                  <a:srgbClr val="222222"/>
-                </a:solidFill>
-              </a:defRPr>
-            </a:pPr>
-            <a:r>
-              <a:t>• characteristics. Scientific Reports, 8:1686.</a:t>
+              <a:t>• Duval, A., Obadia, T., Martinet, L., Boëlle, P.Y., Fleury, E., Guillemot, D., et al. (2018). Measuring dynamic social contacts in a rehabilitation hospital: effect of wards, patient and staff characteristics. Scientific Reports, 8:1686.</a:t>
             </a:r>
           </a:p>
         </p:txBody>

</xml_diff>